<commit_message>
folien: brueckenfolie mit 1:1-zuordnung, hostanteil konkret benannt
</commit_message>
<xml_diff>
--- a/folien/02-adressierung-subnetting-parallelkurs.pptx
+++ b/folien/02-adressierung-subnetting-parallelkurs.pptx
@@ -12883,8 +12883,8 @@
         </p:blipFill>
         <p:spPr>
           <a:xfrm>
-            <a:off x="566928" y="1572768"/>
-            <a:ext cx="8010144" cy="2286000"/>
+            <a:off x="566928" y="1554480"/>
+            <a:ext cx="8010144" cy="2359152"/>
           </a:xfrm>
           <a:prstGeom prst="rect">
             <a:avLst/>
@@ -13197,8 +13197,8 @@
         </p:blipFill>
         <p:spPr>
           <a:xfrm>
-            <a:off x="566928" y="1554480"/>
-            <a:ext cx="8010144" cy="2148840"/>
+            <a:off x="566928" y="1536192"/>
+            <a:ext cx="8010144" cy="2286000"/>
           </a:xfrm>
           <a:prstGeom prst="rect">
             <a:avLst/>
@@ -13258,7 +13258,7 @@
                 <a:ea typeface="Arial" pitchFamily="34" charset="-122"/>
                 <a:cs typeface="Arial" pitchFamily="34" charset="-120"/>
               </a:rPr>
-              <a:t>Die Maske zieht die Grenze: Alles unter den Einsen ist Netz, der Rest gehört dem Gerät.</a:t>
+              <a:t>Vorn das Netz, hinten die Nummer des einzelnen Geräts – egal ob Laptop, Drucker oder Server.</a:t>
             </a:r>
             <a:endParaRPr lang="en-US" sz="1200" dirty="0"/>
           </a:p>

</xml_diff>

<commit_message>
folien: gateway im 26er-block sichtbar, rechnung als gleichung
</commit_message>
<xml_diff>
--- a/folien/02-adressierung-subnetting-parallelkurs.pptx
+++ b/folien/02-adressierung-subnetting-parallelkurs.pptx
@@ -14942,8 +14942,8 @@
         </p:blipFill>
         <p:spPr>
           <a:xfrm>
-            <a:off x="566928" y="1600200"/>
-            <a:ext cx="8010144" cy="1600200"/>
+            <a:off x="566928" y="1691640"/>
+            <a:ext cx="8010144" cy="1956816"/>
           </a:xfrm>
           <a:prstGeom prst="rect">
             <a:avLst/>
@@ -14958,28 +14958,8 @@
         </p:nvSpPr>
         <p:spPr>
           <a:xfrm>
-            <a:off x="566928" y="3383280"/>
-            <a:ext cx="8010144" cy="914400"/>
-          </a:xfrm>
-          <a:prstGeom prst="rect">
-            <a:avLst/>
-          </a:prstGeom>
-          <a:solidFill>
-            <a:srgbClr val="EEF0FB"/>
-          </a:solidFill>
-          <a:ln/>
-        </p:spPr>
-      </p:sp>
-      <p:sp>
-        <p:nvSpPr>
-          <p:cNvPr id="7" name="Shape 4"/>
-          <p:cNvSpPr/>
-          <p:nvPr/>
-        </p:nvSpPr>
-        <p:spPr>
-          <a:xfrm>
-            <a:off x="566928" y="3383280"/>
-            <a:ext cx="41148" cy="914400"/>
+            <a:off x="566928" y="4069080"/>
+            <a:ext cx="32004" cy="256032"/>
           </a:xfrm>
           <a:prstGeom prst="rect">
             <a:avLst/>
@@ -14992,72 +14972,30 @@
       </p:sp>
       <p:sp>
         <p:nvSpPr>
-          <p:cNvPr id="8" name="Text 5"/>
-          <p:cNvSpPr/>
-          <p:nvPr/>
-        </p:nvSpPr>
-        <p:spPr>
-          <a:xfrm>
-            <a:off x="804672" y="3529584"/>
-            <a:ext cx="7607808" cy="242062"/>
-          </a:xfrm>
-          <a:prstGeom prst="rect">
-            <a:avLst/>
-          </a:prstGeom>
-          <a:noFill/>
-          <a:ln/>
-        </p:spPr>
-        <p:txBody>
-          <a:bodyPr wrap="square" lIns="0" tIns="0" rIns="0" bIns="0" rtlCol="0" anchor="t"/>
-          <a:lstStyle/>
-          <a:p>
-            <a:pPr indent="0" marL="0">
-              <a:buNone/>
-            </a:pPr>
-            <a:r>
-              <a:rPr lang="en-US" sz="1300" b="1" dirty="0">
-                <a:solidFill>
-                  <a:srgbClr val="272E52"/>
-                </a:solidFill>
-                <a:latin typeface="Arial" pitchFamily="34" charset="0"/>
-                <a:ea typeface="Arial" pitchFamily="34" charset="-122"/>
-                <a:cs typeface="Arial" pitchFamily="34" charset="-120"/>
-              </a:rPr>
-              <a:t>Und das Gateway?</a:t>
-            </a:r>
-            <a:endParaRPr lang="en-US" sz="1300" dirty="0"/>
-          </a:p>
-        </p:txBody>
-      </p:sp>
-      <p:sp>
-        <p:nvSpPr>
-          <p:cNvPr id="9" name="Text 6"/>
-          <p:cNvSpPr/>
-          <p:nvPr/>
-        </p:nvSpPr>
-        <p:spPr>
-          <a:xfrm>
-            <a:off x="804672" y="3817366"/>
-            <a:ext cx="7607808" cy="361442"/>
-          </a:xfrm>
-          <a:prstGeom prst="rect">
-            <a:avLst/>
-          </a:prstGeom>
-          <a:noFill/>
-          <a:ln/>
-        </p:spPr>
-        <p:txBody>
-          <a:bodyPr wrap="square" lIns="0" tIns="0" rIns="0" bIns="0" rtlCol="0" anchor="t"/>
-          <a:lstStyle/>
-          <a:p>
-            <a:pPr indent="0" marL="0">
-              <a:lnSpc>
-                <a:spcPct val="92000"/>
-              </a:lnSpc>
-              <a:buNone/>
-            </a:pPr>
-            <a:r>
-              <a:rPr lang="en-US" sz="1150" dirty="0">
+          <p:cNvPr id="7" name="Text 4"/>
+          <p:cNvSpPr/>
+          <p:nvPr/>
+        </p:nvSpPr>
+        <p:spPr>
+          <a:xfrm>
+            <a:off x="749808" y="4023360"/>
+            <a:ext cx="7827264" cy="402336"/>
+          </a:xfrm>
+          <a:prstGeom prst="rect">
+            <a:avLst/>
+          </a:prstGeom>
+          <a:noFill/>
+          <a:ln/>
+        </p:spPr>
+        <p:txBody>
+          <a:bodyPr wrap="square" lIns="0" tIns="0" rIns="0" bIns="0" rtlCol="0" anchor="ctr"/>
+          <a:lstStyle/>
+          <a:p>
+            <a:pPr indent="0" marL="0">
+              <a:buNone/>
+            </a:pPr>
+            <a:r>
+              <a:rPr lang="en-US" sz="1200" b="1" dirty="0">
                 <a:solidFill>
                   <a:srgbClr val="434A63"/>
                 </a:solidFill>
@@ -15065,15 +15003,15 @@
                 <a:ea typeface="Arial" pitchFamily="34" charset="-122"/>
                 <a:cs typeface="Arial" pitchFamily="34" charset="-120"/>
               </a:rPr>
-              <a:t>Der Router braucht auch eine Adresse aus dem Block – meist die erste nutzbare. Wer Geräte zählt, plant ihn mit ein: 62 nutzbare heißt 61 für eure Geräte plus das Gateway.</a:t>
-            </a:r>
-            <a:endParaRPr lang="en-US" sz="1150" dirty="0"/>
-          </a:p>
-        </p:txBody>
-      </p:sp>
-      <p:sp>
-        <p:nvSpPr>
-          <p:cNvPr id="10" name="Shape 7"/>
+              <a:t>Wer 64 sagt, hat die zwei Reservierten vergessen – und wer Geräte plant, rechnet das Gateway mit ein: 61 bleiben frei.</a:t>
+            </a:r>
+            <a:endParaRPr lang="en-US" sz="1200" dirty="0"/>
+          </a:p>
+        </p:txBody>
+      </p:sp>
+      <p:sp>
+        <p:nvSpPr>
+          <p:cNvPr id="8" name="Shape 5"/>
           <p:cNvSpPr/>
           <p:nvPr/>
         </p:nvSpPr>
@@ -15096,7 +15034,7 @@
       </p:sp>
       <p:sp>
         <p:nvSpPr>
-          <p:cNvPr id="11" name="Text 8"/>
+          <p:cNvPr id="9" name="Text 6"/>
           <p:cNvSpPr/>
           <p:nvPr/>
         </p:nvSpPr>
@@ -15135,7 +15073,7 @@
       </p:sp>
       <p:sp>
         <p:nvSpPr>
-          <p:cNvPr id="12" name="Text 9"/>
+          <p:cNvPr id="10" name="Text 7"/>
           <p:cNvSpPr/>
           <p:nvPr/>
         </p:nvSpPr>

</xml_diff>

<commit_message>
folien: praefix-tabelle mit bitspalte fuers letzte oktett
</commit_message>
<xml_diff>
--- a/folien/02-adressierung-subnetting-parallelkurs.pptx
+++ b/folien/02-adressierung-subnetting-parallelkurs.pptx
@@ -13931,7 +13931,7 @@
                 <a:ea typeface="Arial" pitchFamily="34" charset="-122"/>
                 <a:cs typeface="Arial" pitchFamily="34" charset="-120"/>
               </a:rPr>
-              <a:t>Euer Werkzeug für heute. Blockgröße = 2 hoch Hostbits – jeder Schritt halbiert.</a:t>
+              <a:t>Euer Werkzeug für heute. In der Maske gilt: Einsen = Netz, Nullen = Gerät.</a:t>
             </a:r>
             <a:endParaRPr lang="en-US" sz="1300" dirty="0"/>
           </a:p>
@@ -13946,7 +13946,7 @@
         <p:spPr>
           <a:xfrm>
             <a:off x="658368" y="1783080"/>
-            <a:ext cx="731520" cy="274320"/>
+            <a:ext cx="594360" cy="274320"/>
           </a:xfrm>
           <a:prstGeom prst="rect">
             <a:avLst/>
@@ -13984,8 +13984,8 @@
         </p:nvSpPr>
         <p:spPr>
           <a:xfrm>
-            <a:off x="1572768" y="1783080"/>
-            <a:ext cx="1737360" cy="274320"/>
+            <a:off x="1435608" y="1783080"/>
+            <a:ext cx="1554480" cy="274320"/>
           </a:xfrm>
           <a:prstGeom prst="rect">
             <a:avLst/>
@@ -14023,8 +14023,8 @@
         </p:nvSpPr>
         <p:spPr>
           <a:xfrm>
-            <a:off x="3493008" y="1783080"/>
-            <a:ext cx="2468880" cy="274320"/>
+            <a:off x="3172968" y="1783080"/>
+            <a:ext cx="1051560" cy="274320"/>
           </a:xfrm>
           <a:prstGeom prst="rect">
             <a:avLst/>
@@ -14048,6 +14048,45 @@
                 <a:ea typeface="Arial" pitchFamily="34" charset="-122"/>
                 <a:cs typeface="Arial" pitchFamily="34" charset="-120"/>
               </a:rPr>
+              <a:t>letztes Oktett</a:t>
+            </a:r>
+            <a:endParaRPr lang="en-US" sz="1050" dirty="0"/>
+          </a:p>
+        </p:txBody>
+      </p:sp>
+      <p:sp>
+        <p:nvSpPr>
+          <p:cNvPr id="9" name="Text 7"/>
+          <p:cNvSpPr/>
+          <p:nvPr/>
+        </p:nvSpPr>
+        <p:spPr>
+          <a:xfrm>
+            <a:off x="4407408" y="1783080"/>
+            <a:ext cx="1691640" cy="274320"/>
+          </a:xfrm>
+          <a:prstGeom prst="rect">
+            <a:avLst/>
+          </a:prstGeom>
+          <a:noFill/>
+          <a:ln/>
+        </p:spPr>
+        <p:txBody>
+          <a:bodyPr wrap="square" lIns="0" tIns="0" rIns="0" bIns="0" rtlCol="0" anchor="ctr"/>
+          <a:lstStyle/>
+          <a:p>
+            <a:pPr indent="0" marL="0">
+              <a:buNone/>
+            </a:pPr>
+            <a:r>
+              <a:rPr lang="en-US" sz="1050" b="1" spc="80" kern="0" dirty="0">
+                <a:solidFill>
+                  <a:srgbClr val="3843AF"/>
+                </a:solidFill>
+                <a:latin typeface="Arial" pitchFamily="34" charset="0"/>
+                <a:ea typeface="Arial" pitchFamily="34" charset="-122"/>
+                <a:cs typeface="Arial" pitchFamily="34" charset="-120"/>
+              </a:rPr>
               <a:t>Blockgröße · nutzbar</a:t>
             </a:r>
             <a:endParaRPr lang="en-US" sz="1050" dirty="0"/>
@@ -14056,14 +14095,14 @@
       </p:sp>
       <p:sp>
         <p:nvSpPr>
-          <p:cNvPr id="9" name="Shape 7"/>
+          <p:cNvPr id="10" name="Shape 8"/>
           <p:cNvSpPr/>
           <p:nvPr/>
         </p:nvSpPr>
         <p:spPr>
           <a:xfrm>
             <a:off x="566928" y="2075688"/>
-            <a:ext cx="5486400" cy="0"/>
+            <a:ext cx="5623560" cy="0"/>
           </a:xfrm>
           <a:prstGeom prst="line">
             <a:avLst/>
@@ -14079,14 +14118,14 @@
       </p:sp>
       <p:sp>
         <p:nvSpPr>
-          <p:cNvPr id="10" name="Shape 8"/>
+          <p:cNvPr id="11" name="Shape 9"/>
           <p:cNvSpPr/>
           <p:nvPr/>
         </p:nvSpPr>
         <p:spPr>
           <a:xfrm>
             <a:off x="475488" y="2148840"/>
-            <a:ext cx="5669280" cy="283464"/>
+            <a:ext cx="5806440" cy="283464"/>
           </a:xfrm>
           <a:prstGeom prst="rect">
             <a:avLst/>
@@ -14099,14 +14138,14 @@
       </p:sp>
       <p:sp>
         <p:nvSpPr>
-          <p:cNvPr id="11" name="Text 9"/>
+          <p:cNvPr id="12" name="Text 10"/>
           <p:cNvSpPr/>
           <p:nvPr/>
         </p:nvSpPr>
         <p:spPr>
           <a:xfrm>
             <a:off x="658368" y="2148840"/>
-            <a:ext cx="731520" cy="283464"/>
+            <a:ext cx="594360" cy="283464"/>
           </a:xfrm>
           <a:prstGeom prst="rect">
             <a:avLst/>
@@ -14138,14 +14177,14 @@
       </p:sp>
       <p:sp>
         <p:nvSpPr>
-          <p:cNvPr id="12" name="Text 10"/>
-          <p:cNvSpPr/>
-          <p:nvPr/>
-        </p:nvSpPr>
-        <p:spPr>
-          <a:xfrm>
-            <a:off x="1572768" y="2148840"/>
-            <a:ext cx="1737360" cy="283464"/>
+          <p:cNvPr id="13" name="Text 11"/>
+          <p:cNvSpPr/>
+          <p:nvPr/>
+        </p:nvSpPr>
+        <p:spPr>
+          <a:xfrm>
+            <a:off x="1435608" y="2148840"/>
+            <a:ext cx="1554480" cy="283464"/>
           </a:xfrm>
           <a:prstGeom prst="rect">
             <a:avLst/>
@@ -14177,14 +14216,14 @@
       </p:sp>
       <p:sp>
         <p:nvSpPr>
-          <p:cNvPr id="13" name="Text 11"/>
-          <p:cNvSpPr/>
-          <p:nvPr/>
-        </p:nvSpPr>
-        <p:spPr>
-          <a:xfrm>
-            <a:off x="3493008" y="2148840"/>
-            <a:ext cx="2468880" cy="283464"/>
+          <p:cNvPr id="14" name="Text 12"/>
+          <p:cNvSpPr/>
+          <p:nvPr/>
+        </p:nvSpPr>
+        <p:spPr>
+          <a:xfrm>
+            <a:off x="3172968" y="2148840"/>
+            <a:ext cx="1051560" cy="283464"/>
           </a:xfrm>
           <a:prstGeom prst="rect">
             <a:avLst/>
@@ -14202,6 +14241,45 @@
             <a:r>
               <a:rPr lang="en-US" sz="1100" dirty="0">
                 <a:solidFill>
+                  <a:srgbClr val="9A6310"/>
+                </a:solidFill>
+                <a:latin typeface="Arial" pitchFamily="34" charset="0"/>
+                <a:ea typeface="Arial" pitchFamily="34" charset="-122"/>
+                <a:cs typeface="Arial" pitchFamily="34" charset="-120"/>
+              </a:rPr>
+              <a:t>00000000</a:t>
+            </a:r>
+            <a:endParaRPr lang="en-US" sz="1100" dirty="0"/>
+          </a:p>
+        </p:txBody>
+      </p:sp>
+      <p:sp>
+        <p:nvSpPr>
+          <p:cNvPr id="15" name="Text 13"/>
+          <p:cNvSpPr/>
+          <p:nvPr/>
+        </p:nvSpPr>
+        <p:spPr>
+          <a:xfrm>
+            <a:off x="4407408" y="2148840"/>
+            <a:ext cx="1691640" cy="283464"/>
+          </a:xfrm>
+          <a:prstGeom prst="rect">
+            <a:avLst/>
+          </a:prstGeom>
+          <a:noFill/>
+          <a:ln/>
+        </p:spPr>
+        <p:txBody>
+          <a:bodyPr wrap="square" lIns="0" tIns="0" rIns="0" bIns="0" rtlCol="0" anchor="ctr"/>
+          <a:lstStyle/>
+          <a:p>
+            <a:pPr indent="0" marL="0">
+              <a:buNone/>
+            </a:pPr>
+            <a:r>
+              <a:rPr lang="en-US" sz="1100" dirty="0">
+                <a:solidFill>
                   <a:srgbClr val="434A63"/>
                 </a:solidFill>
                 <a:latin typeface="Arial" pitchFamily="34" charset="0"/>
@@ -14216,14 +14294,14 @@
       </p:sp>
       <p:sp>
         <p:nvSpPr>
-          <p:cNvPr id="14" name="Text 12"/>
+          <p:cNvPr id="16" name="Text 14"/>
           <p:cNvSpPr/>
           <p:nvPr/>
         </p:nvSpPr>
         <p:spPr>
           <a:xfrm>
             <a:off x="658368" y="2432304"/>
-            <a:ext cx="731520" cy="283464"/>
+            <a:ext cx="594360" cy="283464"/>
           </a:xfrm>
           <a:prstGeom prst="rect">
             <a:avLst/>
@@ -14255,14 +14333,14 @@
       </p:sp>
       <p:sp>
         <p:nvSpPr>
-          <p:cNvPr id="15" name="Text 13"/>
-          <p:cNvSpPr/>
-          <p:nvPr/>
-        </p:nvSpPr>
-        <p:spPr>
-          <a:xfrm>
-            <a:off x="1572768" y="2432304"/>
-            <a:ext cx="1737360" cy="283464"/>
+          <p:cNvPr id="17" name="Text 15"/>
+          <p:cNvSpPr/>
+          <p:nvPr/>
+        </p:nvSpPr>
+        <p:spPr>
+          <a:xfrm>
+            <a:off x="1435608" y="2432304"/>
+            <a:ext cx="1554480" cy="283464"/>
           </a:xfrm>
           <a:prstGeom prst="rect">
             <a:avLst/>
@@ -14294,31 +14372,84 @@
       </p:sp>
       <p:sp>
         <p:nvSpPr>
-          <p:cNvPr id="16" name="Text 14"/>
-          <p:cNvSpPr/>
-          <p:nvPr/>
-        </p:nvSpPr>
-        <p:spPr>
-          <a:xfrm>
-            <a:off x="3493008" y="2432304"/>
-            <a:ext cx="2468880" cy="283464"/>
-          </a:xfrm>
-          <a:prstGeom prst="rect">
-            <a:avLst/>
-          </a:prstGeom>
-          <a:noFill/>
-          <a:ln/>
-        </p:spPr>
-        <p:txBody>
-          <a:bodyPr wrap="square" lIns="0" tIns="0" rIns="0" bIns="0" rtlCol="0" anchor="ctr"/>
-          <a:lstStyle/>
-          <a:p>
+          <p:cNvPr id="18" name="Text 16"/>
+          <p:cNvSpPr/>
+          <p:nvPr/>
+        </p:nvSpPr>
+        <p:spPr>
+          <a:xfrm>
+            <a:off x="3172968" y="2432304"/>
+            <a:ext cx="1051560" cy="283464"/>
+          </a:xfrm>
+          <a:prstGeom prst="rect">
+            <a:avLst/>
+          </a:prstGeom>
+          <a:noFill/>
+          <a:ln/>
+        </p:spPr>
+        <p:txBody>
+          <a:bodyPr wrap="square" lIns="0" tIns="0" rIns="0" bIns="0" rtlCol="0" anchor="ctr"/>
+          <a:lstStyle/>
+          <a:p>
+            <a:pPr indent="0" marL="0">
+              <a:buNone/>
+            </a:pPr>
+            <a:r>
+              <a:rPr lang="en-US" sz="1100" b="1" dirty="0">
+                <a:solidFill>
+                  <a:srgbClr val="3843AF"/>
+                </a:solidFill>
+                <a:latin typeface="Arial" pitchFamily="34" charset="0"/>
+                <a:ea typeface="Arial" pitchFamily="34" charset="-122"/>
+                <a:cs typeface="Arial" pitchFamily="34" charset="-120"/>
+              </a:rPr>
+              <a:t>1</a:t>
+            </a:r>
             <a:pPr indent="0" marL="0">
               <a:buNone/>
             </a:pPr>
             <a:r>
               <a:rPr lang="en-US" sz="1100" dirty="0">
                 <a:solidFill>
+                  <a:srgbClr val="9A6310"/>
+                </a:solidFill>
+                <a:latin typeface="Arial" pitchFamily="34" charset="0"/>
+                <a:ea typeface="Arial" pitchFamily="34" charset="-122"/>
+                <a:cs typeface="Arial" pitchFamily="34" charset="-120"/>
+              </a:rPr>
+              <a:t>0000000</a:t>
+            </a:r>
+            <a:endParaRPr lang="en-US" sz="1100" dirty="0"/>
+          </a:p>
+        </p:txBody>
+      </p:sp>
+      <p:sp>
+        <p:nvSpPr>
+          <p:cNvPr id="19" name="Text 17"/>
+          <p:cNvSpPr/>
+          <p:nvPr/>
+        </p:nvSpPr>
+        <p:spPr>
+          <a:xfrm>
+            <a:off x="4407408" y="2432304"/>
+            <a:ext cx="1691640" cy="283464"/>
+          </a:xfrm>
+          <a:prstGeom prst="rect">
+            <a:avLst/>
+          </a:prstGeom>
+          <a:noFill/>
+          <a:ln/>
+        </p:spPr>
+        <p:txBody>
+          <a:bodyPr wrap="square" lIns="0" tIns="0" rIns="0" bIns="0" rtlCol="0" anchor="ctr"/>
+          <a:lstStyle/>
+          <a:p>
+            <a:pPr indent="0" marL="0">
+              <a:buNone/>
+            </a:pPr>
+            <a:r>
+              <a:rPr lang="en-US" sz="1100" dirty="0">
+                <a:solidFill>
                   <a:srgbClr val="434A63"/>
                 </a:solidFill>
                 <a:latin typeface="Arial" pitchFamily="34" charset="0"/>
@@ -14333,14 +14464,14 @@
       </p:sp>
       <p:sp>
         <p:nvSpPr>
-          <p:cNvPr id="17" name="Shape 15"/>
+          <p:cNvPr id="20" name="Shape 18"/>
           <p:cNvSpPr/>
           <p:nvPr/>
         </p:nvSpPr>
         <p:spPr>
           <a:xfrm>
             <a:off x="475488" y="2715768"/>
-            <a:ext cx="5669280" cy="283464"/>
+            <a:ext cx="5806440" cy="283464"/>
           </a:xfrm>
           <a:prstGeom prst="rect">
             <a:avLst/>
@@ -14353,14 +14484,14 @@
       </p:sp>
       <p:sp>
         <p:nvSpPr>
-          <p:cNvPr id="18" name="Text 16"/>
+          <p:cNvPr id="21" name="Text 19"/>
           <p:cNvSpPr/>
           <p:nvPr/>
         </p:nvSpPr>
         <p:spPr>
           <a:xfrm>
             <a:off x="658368" y="2715768"/>
-            <a:ext cx="731520" cy="283464"/>
+            <a:ext cx="594360" cy="283464"/>
           </a:xfrm>
           <a:prstGeom prst="rect">
             <a:avLst/>
@@ -14392,14 +14523,14 @@
       </p:sp>
       <p:sp>
         <p:nvSpPr>
-          <p:cNvPr id="19" name="Text 17"/>
-          <p:cNvSpPr/>
-          <p:nvPr/>
-        </p:nvSpPr>
-        <p:spPr>
-          <a:xfrm>
-            <a:off x="1572768" y="2715768"/>
-            <a:ext cx="1737360" cy="283464"/>
+          <p:cNvPr id="22" name="Text 20"/>
+          <p:cNvSpPr/>
+          <p:nvPr/>
+        </p:nvSpPr>
+        <p:spPr>
+          <a:xfrm>
+            <a:off x="1435608" y="2715768"/>
+            <a:ext cx="1554480" cy="283464"/>
           </a:xfrm>
           <a:prstGeom prst="rect">
             <a:avLst/>
@@ -14431,31 +14562,84 @@
       </p:sp>
       <p:sp>
         <p:nvSpPr>
-          <p:cNvPr id="20" name="Text 18"/>
-          <p:cNvSpPr/>
-          <p:nvPr/>
-        </p:nvSpPr>
-        <p:spPr>
-          <a:xfrm>
-            <a:off x="3493008" y="2715768"/>
-            <a:ext cx="2468880" cy="283464"/>
-          </a:xfrm>
-          <a:prstGeom prst="rect">
-            <a:avLst/>
-          </a:prstGeom>
-          <a:noFill/>
-          <a:ln/>
-        </p:spPr>
-        <p:txBody>
-          <a:bodyPr wrap="square" lIns="0" tIns="0" rIns="0" bIns="0" rtlCol="0" anchor="ctr"/>
-          <a:lstStyle/>
-          <a:p>
+          <p:cNvPr id="23" name="Text 21"/>
+          <p:cNvSpPr/>
+          <p:nvPr/>
+        </p:nvSpPr>
+        <p:spPr>
+          <a:xfrm>
+            <a:off x="3172968" y="2715768"/>
+            <a:ext cx="1051560" cy="283464"/>
+          </a:xfrm>
+          <a:prstGeom prst="rect">
+            <a:avLst/>
+          </a:prstGeom>
+          <a:noFill/>
+          <a:ln/>
+        </p:spPr>
+        <p:txBody>
+          <a:bodyPr wrap="square" lIns="0" tIns="0" rIns="0" bIns="0" rtlCol="0" anchor="ctr"/>
+          <a:lstStyle/>
+          <a:p>
+            <a:pPr indent="0" marL="0">
+              <a:buNone/>
+            </a:pPr>
+            <a:r>
+              <a:rPr lang="en-US" sz="1100" b="1" dirty="0">
+                <a:solidFill>
+                  <a:srgbClr val="3843AF"/>
+                </a:solidFill>
+                <a:latin typeface="Arial" pitchFamily="34" charset="0"/>
+                <a:ea typeface="Arial" pitchFamily="34" charset="-122"/>
+                <a:cs typeface="Arial" pitchFamily="34" charset="-120"/>
+              </a:rPr>
+              <a:t>11</a:t>
+            </a:r>
             <a:pPr indent="0" marL="0">
               <a:buNone/>
             </a:pPr>
             <a:r>
               <a:rPr lang="en-US" sz="1100" dirty="0">
                 <a:solidFill>
+                  <a:srgbClr val="9A6310"/>
+                </a:solidFill>
+                <a:latin typeface="Arial" pitchFamily="34" charset="0"/>
+                <a:ea typeface="Arial" pitchFamily="34" charset="-122"/>
+                <a:cs typeface="Arial" pitchFamily="34" charset="-120"/>
+              </a:rPr>
+              <a:t>000000</a:t>
+            </a:r>
+            <a:endParaRPr lang="en-US" sz="1100" dirty="0"/>
+          </a:p>
+        </p:txBody>
+      </p:sp>
+      <p:sp>
+        <p:nvSpPr>
+          <p:cNvPr id="24" name="Text 22"/>
+          <p:cNvSpPr/>
+          <p:nvPr/>
+        </p:nvSpPr>
+        <p:spPr>
+          <a:xfrm>
+            <a:off x="4407408" y="2715768"/>
+            <a:ext cx="1691640" cy="283464"/>
+          </a:xfrm>
+          <a:prstGeom prst="rect">
+            <a:avLst/>
+          </a:prstGeom>
+          <a:noFill/>
+          <a:ln/>
+        </p:spPr>
+        <p:txBody>
+          <a:bodyPr wrap="square" lIns="0" tIns="0" rIns="0" bIns="0" rtlCol="0" anchor="ctr"/>
+          <a:lstStyle/>
+          <a:p>
+            <a:pPr indent="0" marL="0">
+              <a:buNone/>
+            </a:pPr>
+            <a:r>
+              <a:rPr lang="en-US" sz="1100" dirty="0">
+                <a:solidFill>
                   <a:srgbClr val="434A63"/>
                 </a:solidFill>
                 <a:latin typeface="Arial" pitchFamily="34" charset="0"/>
@@ -14470,14 +14654,14 @@
       </p:sp>
       <p:sp>
         <p:nvSpPr>
-          <p:cNvPr id="21" name="Text 19"/>
+          <p:cNvPr id="25" name="Text 23"/>
           <p:cNvSpPr/>
           <p:nvPr/>
         </p:nvSpPr>
         <p:spPr>
           <a:xfrm>
             <a:off x="658368" y="2999232"/>
-            <a:ext cx="731520" cy="283464"/>
+            <a:ext cx="594360" cy="283464"/>
           </a:xfrm>
           <a:prstGeom prst="rect">
             <a:avLst/>
@@ -14509,14 +14693,14 @@
       </p:sp>
       <p:sp>
         <p:nvSpPr>
-          <p:cNvPr id="22" name="Text 20"/>
-          <p:cNvSpPr/>
-          <p:nvPr/>
-        </p:nvSpPr>
-        <p:spPr>
-          <a:xfrm>
-            <a:off x="1572768" y="2999232"/>
-            <a:ext cx="1737360" cy="283464"/>
+          <p:cNvPr id="26" name="Text 24"/>
+          <p:cNvSpPr/>
+          <p:nvPr/>
+        </p:nvSpPr>
+        <p:spPr>
+          <a:xfrm>
+            <a:off x="1435608" y="2999232"/>
+            <a:ext cx="1554480" cy="283464"/>
           </a:xfrm>
           <a:prstGeom prst="rect">
             <a:avLst/>
@@ -14548,31 +14732,84 @@
       </p:sp>
       <p:sp>
         <p:nvSpPr>
-          <p:cNvPr id="23" name="Text 21"/>
-          <p:cNvSpPr/>
-          <p:nvPr/>
-        </p:nvSpPr>
-        <p:spPr>
-          <a:xfrm>
-            <a:off x="3493008" y="2999232"/>
-            <a:ext cx="2468880" cy="283464"/>
-          </a:xfrm>
-          <a:prstGeom prst="rect">
-            <a:avLst/>
-          </a:prstGeom>
-          <a:noFill/>
-          <a:ln/>
-        </p:spPr>
-        <p:txBody>
-          <a:bodyPr wrap="square" lIns="0" tIns="0" rIns="0" bIns="0" rtlCol="0" anchor="ctr"/>
-          <a:lstStyle/>
-          <a:p>
+          <p:cNvPr id="27" name="Text 25"/>
+          <p:cNvSpPr/>
+          <p:nvPr/>
+        </p:nvSpPr>
+        <p:spPr>
+          <a:xfrm>
+            <a:off x="3172968" y="2999232"/>
+            <a:ext cx="1051560" cy="283464"/>
+          </a:xfrm>
+          <a:prstGeom prst="rect">
+            <a:avLst/>
+          </a:prstGeom>
+          <a:noFill/>
+          <a:ln/>
+        </p:spPr>
+        <p:txBody>
+          <a:bodyPr wrap="square" lIns="0" tIns="0" rIns="0" bIns="0" rtlCol="0" anchor="ctr"/>
+          <a:lstStyle/>
+          <a:p>
+            <a:pPr indent="0" marL="0">
+              <a:buNone/>
+            </a:pPr>
+            <a:r>
+              <a:rPr lang="en-US" sz="1100" b="1" dirty="0">
+                <a:solidFill>
+                  <a:srgbClr val="3843AF"/>
+                </a:solidFill>
+                <a:latin typeface="Arial" pitchFamily="34" charset="0"/>
+                <a:ea typeface="Arial" pitchFamily="34" charset="-122"/>
+                <a:cs typeface="Arial" pitchFamily="34" charset="-120"/>
+              </a:rPr>
+              <a:t>111</a:t>
+            </a:r>
             <a:pPr indent="0" marL="0">
               <a:buNone/>
             </a:pPr>
             <a:r>
               <a:rPr lang="en-US" sz="1100" dirty="0">
                 <a:solidFill>
+                  <a:srgbClr val="9A6310"/>
+                </a:solidFill>
+                <a:latin typeface="Arial" pitchFamily="34" charset="0"/>
+                <a:ea typeface="Arial" pitchFamily="34" charset="-122"/>
+                <a:cs typeface="Arial" pitchFamily="34" charset="-120"/>
+              </a:rPr>
+              <a:t>00000</a:t>
+            </a:r>
+            <a:endParaRPr lang="en-US" sz="1100" dirty="0"/>
+          </a:p>
+        </p:txBody>
+      </p:sp>
+      <p:sp>
+        <p:nvSpPr>
+          <p:cNvPr id="28" name="Text 26"/>
+          <p:cNvSpPr/>
+          <p:nvPr/>
+        </p:nvSpPr>
+        <p:spPr>
+          <a:xfrm>
+            <a:off x="4407408" y="2999232"/>
+            <a:ext cx="1691640" cy="283464"/>
+          </a:xfrm>
+          <a:prstGeom prst="rect">
+            <a:avLst/>
+          </a:prstGeom>
+          <a:noFill/>
+          <a:ln/>
+        </p:spPr>
+        <p:txBody>
+          <a:bodyPr wrap="square" lIns="0" tIns="0" rIns="0" bIns="0" rtlCol="0" anchor="ctr"/>
+          <a:lstStyle/>
+          <a:p>
+            <a:pPr indent="0" marL="0">
+              <a:buNone/>
+            </a:pPr>
+            <a:r>
+              <a:rPr lang="en-US" sz="1100" dirty="0">
+                <a:solidFill>
                   <a:srgbClr val="434A63"/>
                 </a:solidFill>
                 <a:latin typeface="Arial" pitchFamily="34" charset="0"/>
@@ -14587,14 +14824,14 @@
       </p:sp>
       <p:sp>
         <p:nvSpPr>
-          <p:cNvPr id="24" name="Shape 22"/>
+          <p:cNvPr id="29" name="Shape 27"/>
           <p:cNvSpPr/>
           <p:nvPr/>
         </p:nvSpPr>
         <p:spPr>
           <a:xfrm>
             <a:off x="475488" y="3282696"/>
-            <a:ext cx="5669280" cy="283464"/>
+            <a:ext cx="5806440" cy="283464"/>
           </a:xfrm>
           <a:prstGeom prst="rect">
             <a:avLst/>
@@ -14607,14 +14844,14 @@
       </p:sp>
       <p:sp>
         <p:nvSpPr>
-          <p:cNvPr id="25" name="Text 23"/>
+          <p:cNvPr id="30" name="Text 28"/>
           <p:cNvSpPr/>
           <p:nvPr/>
         </p:nvSpPr>
         <p:spPr>
           <a:xfrm>
             <a:off x="658368" y="3282696"/>
-            <a:ext cx="731520" cy="283464"/>
+            <a:ext cx="594360" cy="283464"/>
           </a:xfrm>
           <a:prstGeom prst="rect">
             <a:avLst/>
@@ -14646,14 +14883,14 @@
       </p:sp>
       <p:sp>
         <p:nvSpPr>
-          <p:cNvPr id="26" name="Text 24"/>
-          <p:cNvSpPr/>
-          <p:nvPr/>
-        </p:nvSpPr>
-        <p:spPr>
-          <a:xfrm>
-            <a:off x="1572768" y="3282696"/>
-            <a:ext cx="1737360" cy="283464"/>
+          <p:cNvPr id="31" name="Text 29"/>
+          <p:cNvSpPr/>
+          <p:nvPr/>
+        </p:nvSpPr>
+        <p:spPr>
+          <a:xfrm>
+            <a:off x="1435608" y="3282696"/>
+            <a:ext cx="1554480" cy="283464"/>
           </a:xfrm>
           <a:prstGeom prst="rect">
             <a:avLst/>
@@ -14685,31 +14922,84 @@
       </p:sp>
       <p:sp>
         <p:nvSpPr>
-          <p:cNvPr id="27" name="Text 25"/>
-          <p:cNvSpPr/>
-          <p:nvPr/>
-        </p:nvSpPr>
-        <p:spPr>
-          <a:xfrm>
-            <a:off x="3493008" y="3282696"/>
-            <a:ext cx="2468880" cy="283464"/>
-          </a:xfrm>
-          <a:prstGeom prst="rect">
-            <a:avLst/>
-          </a:prstGeom>
-          <a:noFill/>
-          <a:ln/>
-        </p:spPr>
-        <p:txBody>
-          <a:bodyPr wrap="square" lIns="0" tIns="0" rIns="0" bIns="0" rtlCol="0" anchor="ctr"/>
-          <a:lstStyle/>
-          <a:p>
+          <p:cNvPr id="32" name="Text 30"/>
+          <p:cNvSpPr/>
+          <p:nvPr/>
+        </p:nvSpPr>
+        <p:spPr>
+          <a:xfrm>
+            <a:off x="3172968" y="3282696"/>
+            <a:ext cx="1051560" cy="283464"/>
+          </a:xfrm>
+          <a:prstGeom prst="rect">
+            <a:avLst/>
+          </a:prstGeom>
+          <a:noFill/>
+          <a:ln/>
+        </p:spPr>
+        <p:txBody>
+          <a:bodyPr wrap="square" lIns="0" tIns="0" rIns="0" bIns="0" rtlCol="0" anchor="ctr"/>
+          <a:lstStyle/>
+          <a:p>
+            <a:pPr indent="0" marL="0">
+              <a:buNone/>
+            </a:pPr>
+            <a:r>
+              <a:rPr lang="en-US" sz="1100" b="1" dirty="0">
+                <a:solidFill>
+                  <a:srgbClr val="3843AF"/>
+                </a:solidFill>
+                <a:latin typeface="Arial" pitchFamily="34" charset="0"/>
+                <a:ea typeface="Arial" pitchFamily="34" charset="-122"/>
+                <a:cs typeface="Arial" pitchFamily="34" charset="-120"/>
+              </a:rPr>
+              <a:t>1111</a:t>
+            </a:r>
             <a:pPr indent="0" marL="0">
               <a:buNone/>
             </a:pPr>
             <a:r>
               <a:rPr lang="en-US" sz="1100" dirty="0">
                 <a:solidFill>
+                  <a:srgbClr val="9A6310"/>
+                </a:solidFill>
+                <a:latin typeface="Arial" pitchFamily="34" charset="0"/>
+                <a:ea typeface="Arial" pitchFamily="34" charset="-122"/>
+                <a:cs typeface="Arial" pitchFamily="34" charset="-120"/>
+              </a:rPr>
+              <a:t>0000</a:t>
+            </a:r>
+            <a:endParaRPr lang="en-US" sz="1100" dirty="0"/>
+          </a:p>
+        </p:txBody>
+      </p:sp>
+      <p:sp>
+        <p:nvSpPr>
+          <p:cNvPr id="33" name="Text 31"/>
+          <p:cNvSpPr/>
+          <p:nvPr/>
+        </p:nvSpPr>
+        <p:spPr>
+          <a:xfrm>
+            <a:off x="4407408" y="3282696"/>
+            <a:ext cx="1691640" cy="283464"/>
+          </a:xfrm>
+          <a:prstGeom prst="rect">
+            <a:avLst/>
+          </a:prstGeom>
+          <a:noFill/>
+          <a:ln/>
+        </p:spPr>
+        <p:txBody>
+          <a:bodyPr wrap="square" lIns="0" tIns="0" rIns="0" bIns="0" rtlCol="0" anchor="ctr"/>
+          <a:lstStyle/>
+          <a:p>
+            <a:pPr indent="0" marL="0">
+              <a:buNone/>
+            </a:pPr>
+            <a:r>
+              <a:rPr lang="en-US" sz="1100" dirty="0">
+                <a:solidFill>
                   <a:srgbClr val="434A63"/>
                 </a:solidFill>
                 <a:latin typeface="Arial" pitchFamily="34" charset="0"/>
@@ -14724,14 +15014,14 @@
       </p:sp>
       <p:sp>
         <p:nvSpPr>
-          <p:cNvPr id="28" name="Text 26"/>
+          <p:cNvPr id="34" name="Text 32"/>
           <p:cNvSpPr/>
           <p:nvPr/>
         </p:nvSpPr>
         <p:spPr>
           <a:xfrm>
             <a:off x="658368" y="3566160"/>
-            <a:ext cx="731520" cy="283464"/>
+            <a:ext cx="594360" cy="283464"/>
           </a:xfrm>
           <a:prstGeom prst="rect">
             <a:avLst/>
@@ -14763,14 +15053,14 @@
       </p:sp>
       <p:sp>
         <p:nvSpPr>
-          <p:cNvPr id="29" name="Text 27"/>
-          <p:cNvSpPr/>
-          <p:nvPr/>
-        </p:nvSpPr>
-        <p:spPr>
-          <a:xfrm>
-            <a:off x="1572768" y="3566160"/>
-            <a:ext cx="1737360" cy="283464"/>
+          <p:cNvPr id="35" name="Text 33"/>
+          <p:cNvSpPr/>
+          <p:nvPr/>
+        </p:nvSpPr>
+        <p:spPr>
+          <a:xfrm>
+            <a:off x="1435608" y="3566160"/>
+            <a:ext cx="1554480" cy="283464"/>
           </a:xfrm>
           <a:prstGeom prst="rect">
             <a:avLst/>
@@ -14802,31 +15092,84 @@
       </p:sp>
       <p:sp>
         <p:nvSpPr>
-          <p:cNvPr id="30" name="Text 28"/>
-          <p:cNvSpPr/>
-          <p:nvPr/>
-        </p:nvSpPr>
-        <p:spPr>
-          <a:xfrm>
-            <a:off x="3493008" y="3566160"/>
-            <a:ext cx="2468880" cy="283464"/>
-          </a:xfrm>
-          <a:prstGeom prst="rect">
-            <a:avLst/>
-          </a:prstGeom>
-          <a:noFill/>
-          <a:ln/>
-        </p:spPr>
-        <p:txBody>
-          <a:bodyPr wrap="square" lIns="0" tIns="0" rIns="0" bIns="0" rtlCol="0" anchor="ctr"/>
-          <a:lstStyle/>
-          <a:p>
+          <p:cNvPr id="36" name="Text 34"/>
+          <p:cNvSpPr/>
+          <p:nvPr/>
+        </p:nvSpPr>
+        <p:spPr>
+          <a:xfrm>
+            <a:off x="3172968" y="3566160"/>
+            <a:ext cx="1051560" cy="283464"/>
+          </a:xfrm>
+          <a:prstGeom prst="rect">
+            <a:avLst/>
+          </a:prstGeom>
+          <a:noFill/>
+          <a:ln/>
+        </p:spPr>
+        <p:txBody>
+          <a:bodyPr wrap="square" lIns="0" tIns="0" rIns="0" bIns="0" rtlCol="0" anchor="ctr"/>
+          <a:lstStyle/>
+          <a:p>
+            <a:pPr indent="0" marL="0">
+              <a:buNone/>
+            </a:pPr>
+            <a:r>
+              <a:rPr lang="en-US" sz="1100" b="1" dirty="0">
+                <a:solidFill>
+                  <a:srgbClr val="3843AF"/>
+                </a:solidFill>
+                <a:latin typeface="Arial" pitchFamily="34" charset="0"/>
+                <a:ea typeface="Arial" pitchFamily="34" charset="-122"/>
+                <a:cs typeface="Arial" pitchFamily="34" charset="-120"/>
+              </a:rPr>
+              <a:t>11111</a:t>
+            </a:r>
             <a:pPr indent="0" marL="0">
               <a:buNone/>
             </a:pPr>
             <a:r>
               <a:rPr lang="en-US" sz="1100" dirty="0">
                 <a:solidFill>
+                  <a:srgbClr val="9A6310"/>
+                </a:solidFill>
+                <a:latin typeface="Arial" pitchFamily="34" charset="0"/>
+                <a:ea typeface="Arial" pitchFamily="34" charset="-122"/>
+                <a:cs typeface="Arial" pitchFamily="34" charset="-120"/>
+              </a:rPr>
+              <a:t>000</a:t>
+            </a:r>
+            <a:endParaRPr lang="en-US" sz="1100" dirty="0"/>
+          </a:p>
+        </p:txBody>
+      </p:sp>
+      <p:sp>
+        <p:nvSpPr>
+          <p:cNvPr id="37" name="Text 35"/>
+          <p:cNvSpPr/>
+          <p:nvPr/>
+        </p:nvSpPr>
+        <p:spPr>
+          <a:xfrm>
+            <a:off x="4407408" y="3566160"/>
+            <a:ext cx="1691640" cy="283464"/>
+          </a:xfrm>
+          <a:prstGeom prst="rect">
+            <a:avLst/>
+          </a:prstGeom>
+          <a:noFill/>
+          <a:ln/>
+        </p:spPr>
+        <p:txBody>
+          <a:bodyPr wrap="square" lIns="0" tIns="0" rIns="0" bIns="0" rtlCol="0" anchor="ctr"/>
+          <a:lstStyle/>
+          <a:p>
+            <a:pPr indent="0" marL="0">
+              <a:buNone/>
+            </a:pPr>
+            <a:r>
+              <a:rPr lang="en-US" sz="1100" dirty="0">
+                <a:solidFill>
                   <a:srgbClr val="434A63"/>
                 </a:solidFill>
                 <a:latin typeface="Arial" pitchFamily="34" charset="0"/>
@@ -14841,14 +15184,14 @@
       </p:sp>
       <p:sp>
         <p:nvSpPr>
-          <p:cNvPr id="31" name="Shape 29"/>
+          <p:cNvPr id="38" name="Shape 36"/>
           <p:cNvSpPr/>
           <p:nvPr/>
         </p:nvSpPr>
         <p:spPr>
           <a:xfrm>
             <a:off x="475488" y="3849624"/>
-            <a:ext cx="5669280" cy="283464"/>
+            <a:ext cx="5806440" cy="283464"/>
           </a:xfrm>
           <a:prstGeom prst="rect">
             <a:avLst/>
@@ -14861,14 +15204,14 @@
       </p:sp>
       <p:sp>
         <p:nvSpPr>
-          <p:cNvPr id="32" name="Text 30"/>
+          <p:cNvPr id="39" name="Text 37"/>
           <p:cNvSpPr/>
           <p:nvPr/>
         </p:nvSpPr>
         <p:spPr>
           <a:xfrm>
             <a:off x="658368" y="3849624"/>
-            <a:ext cx="731520" cy="283464"/>
+            <a:ext cx="594360" cy="283464"/>
           </a:xfrm>
           <a:prstGeom prst="rect">
             <a:avLst/>
@@ -14900,14 +15243,14 @@
       </p:sp>
       <p:sp>
         <p:nvSpPr>
-          <p:cNvPr id="33" name="Text 31"/>
-          <p:cNvSpPr/>
-          <p:nvPr/>
-        </p:nvSpPr>
-        <p:spPr>
-          <a:xfrm>
-            <a:off x="1572768" y="3849624"/>
-            <a:ext cx="1737360" cy="283464"/>
+          <p:cNvPr id="40" name="Text 38"/>
+          <p:cNvSpPr/>
+          <p:nvPr/>
+        </p:nvSpPr>
+        <p:spPr>
+          <a:xfrm>
+            <a:off x="1435608" y="3849624"/>
+            <a:ext cx="1554480" cy="283464"/>
           </a:xfrm>
           <a:prstGeom prst="rect">
             <a:avLst/>
@@ -14939,31 +15282,84 @@
       </p:sp>
       <p:sp>
         <p:nvSpPr>
-          <p:cNvPr id="34" name="Text 32"/>
-          <p:cNvSpPr/>
-          <p:nvPr/>
-        </p:nvSpPr>
-        <p:spPr>
-          <a:xfrm>
-            <a:off x="3493008" y="3849624"/>
-            <a:ext cx="2468880" cy="283464"/>
-          </a:xfrm>
-          <a:prstGeom prst="rect">
-            <a:avLst/>
-          </a:prstGeom>
-          <a:noFill/>
-          <a:ln/>
-        </p:spPr>
-        <p:txBody>
-          <a:bodyPr wrap="square" lIns="0" tIns="0" rIns="0" bIns="0" rtlCol="0" anchor="ctr"/>
-          <a:lstStyle/>
-          <a:p>
+          <p:cNvPr id="41" name="Text 39"/>
+          <p:cNvSpPr/>
+          <p:nvPr/>
+        </p:nvSpPr>
+        <p:spPr>
+          <a:xfrm>
+            <a:off x="3172968" y="3849624"/>
+            <a:ext cx="1051560" cy="283464"/>
+          </a:xfrm>
+          <a:prstGeom prst="rect">
+            <a:avLst/>
+          </a:prstGeom>
+          <a:noFill/>
+          <a:ln/>
+        </p:spPr>
+        <p:txBody>
+          <a:bodyPr wrap="square" lIns="0" tIns="0" rIns="0" bIns="0" rtlCol="0" anchor="ctr"/>
+          <a:lstStyle/>
+          <a:p>
+            <a:pPr indent="0" marL="0">
+              <a:buNone/>
+            </a:pPr>
+            <a:r>
+              <a:rPr lang="en-US" sz="1100" b="1" dirty="0">
+                <a:solidFill>
+                  <a:srgbClr val="3843AF"/>
+                </a:solidFill>
+                <a:latin typeface="Arial" pitchFamily="34" charset="0"/>
+                <a:ea typeface="Arial" pitchFamily="34" charset="-122"/>
+                <a:cs typeface="Arial" pitchFamily="34" charset="-120"/>
+              </a:rPr>
+              <a:t>111111</a:t>
+            </a:r>
             <a:pPr indent="0" marL="0">
               <a:buNone/>
             </a:pPr>
             <a:r>
               <a:rPr lang="en-US" sz="1100" dirty="0">
                 <a:solidFill>
+                  <a:srgbClr val="9A6310"/>
+                </a:solidFill>
+                <a:latin typeface="Arial" pitchFamily="34" charset="0"/>
+                <a:ea typeface="Arial" pitchFamily="34" charset="-122"/>
+                <a:cs typeface="Arial" pitchFamily="34" charset="-120"/>
+              </a:rPr>
+              <a:t>00</a:t>
+            </a:r>
+            <a:endParaRPr lang="en-US" sz="1100" dirty="0"/>
+          </a:p>
+        </p:txBody>
+      </p:sp>
+      <p:sp>
+        <p:nvSpPr>
+          <p:cNvPr id="42" name="Text 40"/>
+          <p:cNvSpPr/>
+          <p:nvPr/>
+        </p:nvSpPr>
+        <p:spPr>
+          <a:xfrm>
+            <a:off x="4407408" y="3849624"/>
+            <a:ext cx="1691640" cy="283464"/>
+          </a:xfrm>
+          <a:prstGeom prst="rect">
+            <a:avLst/>
+          </a:prstGeom>
+          <a:noFill/>
+          <a:ln/>
+        </p:spPr>
+        <p:txBody>
+          <a:bodyPr wrap="square" lIns="0" tIns="0" rIns="0" bIns="0" rtlCol="0" anchor="ctr"/>
+          <a:lstStyle/>
+          <a:p>
+            <a:pPr indent="0" marL="0">
+              <a:buNone/>
+            </a:pPr>
+            <a:r>
+              <a:rPr lang="en-US" sz="1100" dirty="0">
+                <a:solidFill>
                   <a:srgbClr val="434A63"/>
                 </a:solidFill>
                 <a:latin typeface="Arial" pitchFamily="34" charset="0"/>
@@ -14978,7 +15374,7 @@
       </p:sp>
       <p:sp>
         <p:nvSpPr>
-          <p:cNvPr id="35" name="Text 33"/>
+          <p:cNvPr id="43" name="Text 41"/>
           <p:cNvSpPr/>
           <p:nvPr/>
         </p:nvSpPr>
@@ -15017,7 +15413,7 @@
       </p:sp>
       <p:pic>
         <p:nvPicPr>
-          <p:cNvPr id="36" name="Image 0" descr="/Users/jacobmenge/Desktop/kurs-26.2b-orga/folienwerkstatt/assets/diagramme/praefix-balken.png">    </p:cNvPr>
+          <p:cNvPr id="44" name="Image 0" descr="/Users/jacobmenge/Desktop/kurs-26.2b-orga/folienwerkstatt/assets/diagramme/praefix-balken.png">    </p:cNvPr>
           <p:cNvPicPr>
             <a:picLocks noChangeAspect="1"/>
           </p:cNvPicPr>
@@ -15041,7 +15437,7 @@
       </p:pic>
       <p:sp>
         <p:nvSpPr>
-          <p:cNvPr id="37" name="Shape 34"/>
+          <p:cNvPr id="45" name="Shape 42"/>
           <p:cNvSpPr/>
           <p:nvPr/>
         </p:nvSpPr>
@@ -15061,7 +15457,7 @@
       </p:sp>
       <p:sp>
         <p:nvSpPr>
-          <p:cNvPr id="38" name="Text 35"/>
+          <p:cNvPr id="46" name="Text 43"/>
           <p:cNvSpPr/>
           <p:nvPr/>
         </p:nvSpPr>
@@ -15100,7 +15496,7 @@
       </p:sp>
       <p:sp>
         <p:nvSpPr>
-          <p:cNvPr id="39" name="Shape 36"/>
+          <p:cNvPr id="47" name="Shape 44"/>
           <p:cNvSpPr/>
           <p:nvPr/>
         </p:nvSpPr>
@@ -15123,7 +15519,7 @@
       </p:sp>
       <p:sp>
         <p:nvSpPr>
-          <p:cNvPr id="40" name="Text 37"/>
+          <p:cNvPr id="48" name="Text 45"/>
           <p:cNvSpPr/>
           <p:nvPr/>
         </p:nvSpPr>
@@ -15162,7 +15558,7 @@
       </p:sp>
       <p:sp>
         <p:nvSpPr>
-          <p:cNvPr id="41" name="Text 38"/>
+          <p:cNvPr id="49" name="Text 46"/>
           <p:cNvSpPr/>
           <p:nvPr/>
         </p:nvSpPr>

</xml_diff>

<commit_message>
folien: rezept mit sichtbaren bits, loesungsweg unter jeder aufgabe
</commit_message>
<xml_diff>
--- a/folien/02-adressierung-subnetting-parallelkurs.pptx
+++ b/folien/02-adressierung-subnetting-parallelkurs.pptx
@@ -4034,8 +4034,8 @@
         </p:blipFill>
         <p:spPr>
           <a:xfrm>
-            <a:off x="566928" y="1536192"/>
-            <a:ext cx="8010144" cy="2468880"/>
+            <a:off x="566928" y="1426464"/>
+            <a:ext cx="8010144" cy="2743200"/>
           </a:xfrm>
           <a:prstGeom prst="rect">
             <a:avLst/>
@@ -4050,7 +4050,7 @@
         </p:nvSpPr>
         <p:spPr>
           <a:xfrm>
-            <a:off x="566928" y="4206240"/>
+            <a:off x="566928" y="4288536"/>
             <a:ext cx="32004" cy="256032"/>
           </a:xfrm>
           <a:prstGeom prst="rect">
@@ -4070,7 +4070,7 @@
         </p:nvSpPr>
         <p:spPr>
           <a:xfrm>
-            <a:off x="749808" y="4160520"/>
+            <a:off x="749808" y="4242816"/>
             <a:ext cx="7827264" cy="402336"/>
           </a:xfrm>
           <a:prstGeom prst="rect">
@@ -4672,7 +4672,7 @@
       </p:pic>
       <p:pic>
         <p:nvPicPr>
-          <p:cNvPr id="6" name="Image 1" descr="/Users/jacobmenge/Desktop/kurs-26.2b-orga/folienwerkstatt/assets/diagramme/block-strahl.png">    </p:cNvPr>
+          <p:cNvPr id="6" name="Image 1" descr="/Users/jacobmenge/Desktop/kurs-26.2b-orga/folienwerkstatt/assets/diagramme/loesungsweg-a.png">    </p:cNvPr>
           <p:cNvPicPr>
             <a:picLocks noChangeAspect="1"/>
           </p:cNvPicPr>
@@ -4686,8 +4686,8 @@
         </p:blipFill>
         <p:spPr>
           <a:xfrm>
-            <a:off x="566928" y="3200400"/>
-            <a:ext cx="8010144" cy="1115568"/>
+            <a:off x="566928" y="3310128"/>
+            <a:ext cx="8010144" cy="877824"/>
           </a:xfrm>
           <a:prstGeom prst="rect">
             <a:avLst/>
@@ -5255,7 +5255,7 @@
         </p:blipFill>
         <p:spPr>
           <a:xfrm>
-            <a:off x="566928" y="1874520"/>
+            <a:off x="566928" y="1572768"/>
             <a:ext cx="8010144" cy="1536192"/>
           </a:xfrm>
           <a:prstGeom prst="rect">
@@ -5263,68 +5263,33 @@
           </a:prstGeom>
         </p:spPr>
       </p:pic>
-      <p:sp>
-        <p:nvSpPr>
-          <p:cNvPr id="6" name="Shape 3"/>
-          <p:cNvSpPr/>
-          <p:nvPr/>
-        </p:nvSpPr>
-        <p:spPr>
-          <a:xfrm>
-            <a:off x="566928" y="4160520"/>
-            <a:ext cx="32004" cy="256032"/>
-          </a:xfrm>
-          <a:prstGeom prst="rect">
-            <a:avLst/>
-          </a:prstGeom>
-          <a:solidFill>
-            <a:srgbClr val="0F7C86"/>
-          </a:solidFill>
-          <a:ln/>
-        </p:spPr>
-      </p:sp>
-      <p:sp>
-        <p:nvSpPr>
-          <p:cNvPr id="7" name="Text 4"/>
-          <p:cNvSpPr/>
-          <p:nvPr/>
-        </p:nvSpPr>
-        <p:spPr>
-          <a:xfrm>
-            <a:off x="749808" y="4114800"/>
-            <a:ext cx="7827264" cy="402336"/>
-          </a:xfrm>
-          <a:prstGeom prst="rect">
-            <a:avLst/>
-          </a:prstGeom>
-          <a:noFill/>
-          <a:ln/>
-        </p:spPr>
-        <p:txBody>
-          <a:bodyPr wrap="square" lIns="0" tIns="0" rIns="0" bIns="0" rtlCol="0" anchor="ctr"/>
-          <a:lstStyle/>
-          <a:p>
-            <a:pPr indent="0" marL="0">
-              <a:buNone/>
-            </a:pPr>
-            <a:r>
-              <a:rPr lang="en-US" sz="1200" b="1" dirty="0">
-                <a:solidFill>
-                  <a:srgbClr val="5C6377"/>
-                </a:solidFill>
-                <a:latin typeface="Arial" pitchFamily="34" charset="0"/>
-                <a:ea typeface="Arial" pitchFamily="34" charset="-122"/>
-                <a:cs typeface="Arial" pitchFamily="34" charset="-120"/>
-              </a:rPr>
-              <a:t>Das Rezept: Hostbits → Blockgröße → Block finden → minus zwei.</a:t>
-            </a:r>
-            <a:endParaRPr lang="en-US" sz="1200" dirty="0"/>
-          </a:p>
-        </p:txBody>
-      </p:sp>
-      <p:sp>
-        <p:nvSpPr>
-          <p:cNvPr id="8" name="Shape 5"/>
+      <p:pic>
+        <p:nvPicPr>
+          <p:cNvPr id="6" name="Image 1" descr="/Users/jacobmenge/Desktop/kurs-26.2b-orga/folienwerkstatt/assets/diagramme/loesungsweg-b.png">    </p:cNvPr>
+          <p:cNvPicPr>
+            <a:picLocks noChangeAspect="1"/>
+          </p:cNvPicPr>
+          <p:nvPr/>
+        </p:nvPicPr>
+        <p:blipFill>
+          <a:blip r:embed="rId2"/>
+          <a:stretch>
+            <a:fillRect/>
+          </a:stretch>
+        </p:blipFill>
+        <p:spPr>
+          <a:xfrm>
+            <a:off x="566928" y="3310128"/>
+            <a:ext cx="8010144" cy="877824"/>
+          </a:xfrm>
+          <a:prstGeom prst="rect">
+            <a:avLst/>
+          </a:prstGeom>
+        </p:spPr>
+      </p:pic>
+      <p:sp>
+        <p:nvSpPr>
+          <p:cNvPr id="7" name="Shape 3"/>
           <p:cNvSpPr/>
           <p:nvPr/>
         </p:nvSpPr>
@@ -5347,7 +5312,7 @@
       </p:sp>
       <p:sp>
         <p:nvSpPr>
-          <p:cNvPr id="9" name="Text 6"/>
+          <p:cNvPr id="8" name="Text 4"/>
           <p:cNvSpPr/>
           <p:nvPr/>
         </p:nvSpPr>
@@ -5386,7 +5351,7 @@
       </p:sp>
       <p:sp>
         <p:nvSpPr>
-          <p:cNvPr id="10" name="Text 7"/>
+          <p:cNvPr id="9" name="Text 5"/>
           <p:cNvSpPr/>
           <p:nvPr/>
         </p:nvSpPr>
@@ -5883,7 +5848,7 @@
         </p:blipFill>
         <p:spPr>
           <a:xfrm>
-            <a:off x="566928" y="1874520"/>
+            <a:off x="566928" y="1572768"/>
             <a:ext cx="8010144" cy="1536192"/>
           </a:xfrm>
           <a:prstGeom prst="rect">
@@ -5891,68 +5856,33 @@
           </a:prstGeom>
         </p:spPr>
       </p:pic>
-      <p:sp>
-        <p:nvSpPr>
-          <p:cNvPr id="6" name="Shape 3"/>
-          <p:cNvSpPr/>
-          <p:nvPr/>
-        </p:nvSpPr>
-        <p:spPr>
-          <a:xfrm>
-            <a:off x="566928" y="4160520"/>
-            <a:ext cx="32004" cy="256032"/>
-          </a:xfrm>
-          <a:prstGeom prst="rect">
-            <a:avLst/>
-          </a:prstGeom>
-          <a:solidFill>
-            <a:srgbClr val="0F7C86"/>
-          </a:solidFill>
-          <a:ln/>
-        </p:spPr>
-      </p:sp>
-      <p:sp>
-        <p:nvSpPr>
-          <p:cNvPr id="7" name="Text 4"/>
-          <p:cNvSpPr/>
-          <p:nvPr/>
-        </p:nvSpPr>
-        <p:spPr>
-          <a:xfrm>
-            <a:off x="749808" y="4114800"/>
-            <a:ext cx="7827264" cy="402336"/>
-          </a:xfrm>
-          <a:prstGeom prst="rect">
-            <a:avLst/>
-          </a:prstGeom>
-          <a:noFill/>
-          <a:ln/>
-        </p:spPr>
-        <p:txBody>
-          <a:bodyPr wrap="square" lIns="0" tIns="0" rIns="0" bIns="0" rtlCol="0" anchor="ctr"/>
-          <a:lstStyle/>
-          <a:p>
-            <a:pPr indent="0" marL="0">
-              <a:buNone/>
-            </a:pPr>
-            <a:r>
-              <a:rPr lang="en-US" sz="1200" b="1" dirty="0">
-                <a:solidFill>
-                  <a:srgbClr val="5C6377"/>
-                </a:solidFill>
-                <a:latin typeface="Arial" pitchFamily="34" charset="0"/>
-                <a:ea typeface="Arial" pitchFamily="34" charset="-122"/>
-                <a:cs typeface="Arial" pitchFamily="34" charset="-120"/>
-              </a:rPr>
-              <a:t>Das Rezept: Hostbits → Blockgröße → Block finden → minus zwei.</a:t>
-            </a:r>
-            <a:endParaRPr lang="en-US" sz="1200" dirty="0"/>
-          </a:p>
-        </p:txBody>
-      </p:sp>
-      <p:sp>
-        <p:nvSpPr>
-          <p:cNvPr id="8" name="Shape 5"/>
+      <p:pic>
+        <p:nvPicPr>
+          <p:cNvPr id="6" name="Image 1" descr="/Users/jacobmenge/Desktop/kurs-26.2b-orga/folienwerkstatt/assets/diagramme/loesungsweg-c.png">    </p:cNvPr>
+          <p:cNvPicPr>
+            <a:picLocks noChangeAspect="1"/>
+          </p:cNvPicPr>
+          <p:nvPr/>
+        </p:nvPicPr>
+        <p:blipFill>
+          <a:blip r:embed="rId2"/>
+          <a:stretch>
+            <a:fillRect/>
+          </a:stretch>
+        </p:blipFill>
+        <p:spPr>
+          <a:xfrm>
+            <a:off x="566928" y="3310128"/>
+            <a:ext cx="8010144" cy="877824"/>
+          </a:xfrm>
+          <a:prstGeom prst="rect">
+            <a:avLst/>
+          </a:prstGeom>
+        </p:spPr>
+      </p:pic>
+      <p:sp>
+        <p:nvSpPr>
+          <p:cNvPr id="7" name="Shape 3"/>
           <p:cNvSpPr/>
           <p:nvPr/>
         </p:nvSpPr>
@@ -5975,7 +5905,7 @@
       </p:sp>
       <p:sp>
         <p:nvSpPr>
-          <p:cNvPr id="9" name="Text 6"/>
+          <p:cNvPr id="8" name="Text 4"/>
           <p:cNvSpPr/>
           <p:nvPr/>
         </p:nvSpPr>
@@ -6014,7 +5944,7 @@
       </p:sp>
       <p:sp>
         <p:nvSpPr>
-          <p:cNvPr id="10" name="Text 7"/>
+          <p:cNvPr id="9" name="Text 5"/>
           <p:cNvSpPr/>
           <p:nvPr/>
         </p:nvSpPr>

</xml_diff>

<commit_message>
folien: musterloesung mit subnetz-balken, blockgroessen-rechenwege verknuepft
</commit_message>
<xml_diff>
--- a/folien/02-adressierung-subnetting-parallelkurs.pptx
+++ b/folien/02-adressierung-subnetting-parallelkurs.pptx
@@ -11190,7 +11190,7 @@
         </p:nvSpPr>
         <p:spPr>
           <a:xfrm>
-            <a:off x="658368" y="1737360"/>
+            <a:off x="658368" y="1627632"/>
             <a:ext cx="1554480" cy="274320"/>
           </a:xfrm>
           <a:prstGeom prst="rect">
@@ -11229,7 +11229,7 @@
         </p:nvSpPr>
         <p:spPr>
           <a:xfrm>
-            <a:off x="2395728" y="1737360"/>
+            <a:off x="2395728" y="1627632"/>
             <a:ext cx="731520" cy="274320"/>
           </a:xfrm>
           <a:prstGeom prst="rect">
@@ -11268,7 +11268,7 @@
         </p:nvSpPr>
         <p:spPr>
           <a:xfrm>
-            <a:off x="3310128" y="1737360"/>
+            <a:off x="3310128" y="1627632"/>
             <a:ext cx="5175504" cy="274320"/>
           </a:xfrm>
           <a:prstGeom prst="rect">
@@ -11307,7 +11307,7 @@
         </p:nvSpPr>
         <p:spPr>
           <a:xfrm>
-            <a:off x="566928" y="2029968"/>
+            <a:off x="566928" y="1920240"/>
             <a:ext cx="8010144" cy="0"/>
           </a:xfrm>
           <a:prstGeom prst="line">
@@ -11330,8 +11330,8 @@
         </p:nvSpPr>
         <p:spPr>
           <a:xfrm>
-            <a:off x="475488" y="2103120"/>
-            <a:ext cx="8193024" cy="365760"/>
+            <a:off x="475488" y="1993392"/>
+            <a:ext cx="8193024" cy="310896"/>
           </a:xfrm>
           <a:prstGeom prst="rect">
             <a:avLst/>
@@ -11350,8 +11350,8 @@
         </p:nvSpPr>
         <p:spPr>
           <a:xfrm>
-            <a:off x="658368" y="2103120"/>
-            <a:ext cx="1554480" cy="365760"/>
+            <a:off x="658368" y="1993392"/>
+            <a:ext cx="1554480" cy="310896"/>
           </a:xfrm>
           <a:prstGeom prst="rect">
             <a:avLst/>
@@ -11389,8 +11389,8 @@
         </p:nvSpPr>
         <p:spPr>
           <a:xfrm>
-            <a:off x="2395728" y="2103120"/>
-            <a:ext cx="731520" cy="365760"/>
+            <a:off x="2395728" y="1993392"/>
+            <a:ext cx="731520" cy="310896"/>
           </a:xfrm>
           <a:prstGeom prst="rect">
             <a:avLst/>
@@ -11428,8 +11428,8 @@
         </p:nvSpPr>
         <p:spPr>
           <a:xfrm>
-            <a:off x="3310128" y="2103120"/>
-            <a:ext cx="5175504" cy="365760"/>
+            <a:off x="3310128" y="1993392"/>
+            <a:ext cx="5175504" cy="310896"/>
           </a:xfrm>
           <a:prstGeom prst="rect">
             <a:avLst/>
@@ -11467,8 +11467,8 @@
         </p:nvSpPr>
         <p:spPr>
           <a:xfrm>
-            <a:off x="658368" y="2468880"/>
-            <a:ext cx="1554480" cy="365760"/>
+            <a:off x="658368" y="2304288"/>
+            <a:ext cx="1554480" cy="310896"/>
           </a:xfrm>
           <a:prstGeom prst="rect">
             <a:avLst/>
@@ -11506,8 +11506,8 @@
         </p:nvSpPr>
         <p:spPr>
           <a:xfrm>
-            <a:off x="2395728" y="2468880"/>
-            <a:ext cx="731520" cy="365760"/>
+            <a:off x="2395728" y="2304288"/>
+            <a:ext cx="731520" cy="310896"/>
           </a:xfrm>
           <a:prstGeom prst="rect">
             <a:avLst/>
@@ -11545,8 +11545,8 @@
         </p:nvSpPr>
         <p:spPr>
           <a:xfrm>
-            <a:off x="3310128" y="2468880"/>
-            <a:ext cx="5175504" cy="365760"/>
+            <a:off x="3310128" y="2304288"/>
+            <a:ext cx="5175504" cy="310896"/>
           </a:xfrm>
           <a:prstGeom prst="rect">
             <a:avLst/>
@@ -11584,8 +11584,8 @@
         </p:nvSpPr>
         <p:spPr>
           <a:xfrm>
-            <a:off x="475488" y="2834640"/>
-            <a:ext cx="8193024" cy="365760"/>
+            <a:off x="475488" y="2615184"/>
+            <a:ext cx="8193024" cy="310896"/>
           </a:xfrm>
           <a:prstGeom prst="rect">
             <a:avLst/>
@@ -11604,8 +11604,8 @@
         </p:nvSpPr>
         <p:spPr>
           <a:xfrm>
-            <a:off x="658368" y="2834640"/>
-            <a:ext cx="1554480" cy="365760"/>
+            <a:off x="658368" y="2615184"/>
+            <a:ext cx="1554480" cy="310896"/>
           </a:xfrm>
           <a:prstGeom prst="rect">
             <a:avLst/>
@@ -11643,8 +11643,8 @@
         </p:nvSpPr>
         <p:spPr>
           <a:xfrm>
-            <a:off x="2395728" y="2834640"/>
-            <a:ext cx="731520" cy="365760"/>
+            <a:off x="2395728" y="2615184"/>
+            <a:ext cx="731520" cy="310896"/>
           </a:xfrm>
           <a:prstGeom prst="rect">
             <a:avLst/>
@@ -11682,8 +11682,8 @@
         </p:nvSpPr>
         <p:spPr>
           <a:xfrm>
-            <a:off x="3310128" y="2834640"/>
-            <a:ext cx="5175504" cy="365760"/>
+            <a:off x="3310128" y="2615184"/>
+            <a:ext cx="5175504" cy="310896"/>
           </a:xfrm>
           <a:prstGeom prst="rect">
             <a:avLst/>
@@ -11721,8 +11721,8 @@
         </p:nvSpPr>
         <p:spPr>
           <a:xfrm>
-            <a:off x="658368" y="3200400"/>
-            <a:ext cx="1554480" cy="365760"/>
+            <a:off x="658368" y="2926080"/>
+            <a:ext cx="1554480" cy="310896"/>
           </a:xfrm>
           <a:prstGeom prst="rect">
             <a:avLst/>
@@ -11760,8 +11760,8 @@
         </p:nvSpPr>
         <p:spPr>
           <a:xfrm>
-            <a:off x="2395728" y="3200400"/>
-            <a:ext cx="731520" cy="365760"/>
+            <a:off x="2395728" y="2926080"/>
+            <a:ext cx="731520" cy="310896"/>
           </a:xfrm>
           <a:prstGeom prst="rect">
             <a:avLst/>
@@ -11799,8 +11799,8 @@
         </p:nvSpPr>
         <p:spPr>
           <a:xfrm>
-            <a:off x="3310128" y="3200400"/>
-            <a:ext cx="5175504" cy="365760"/>
+            <a:off x="3310128" y="2926080"/>
+            <a:ext cx="5175504" cy="310896"/>
           </a:xfrm>
           <a:prstGeom prst="rect">
             <a:avLst/>
@@ -11830,152 +11830,39 @@
           </a:p>
         </p:txBody>
       </p:sp>
-      <p:sp>
-        <p:nvSpPr>
-          <p:cNvPr id="23" name="Shape 21"/>
-          <p:cNvSpPr/>
-          <p:nvPr/>
-        </p:nvSpPr>
-        <p:spPr>
-          <a:xfrm>
-            <a:off x="475488" y="3566160"/>
-            <a:ext cx="8193024" cy="365760"/>
-          </a:xfrm>
-          <a:prstGeom prst="rect">
-            <a:avLst/>
-          </a:prstGeom>
-          <a:solidFill>
-            <a:srgbClr val="F5F6FC"/>
-          </a:solidFill>
-          <a:ln/>
-        </p:spPr>
-      </p:sp>
-      <p:sp>
-        <p:nvSpPr>
-          <p:cNvPr id="24" name="Text 22"/>
-          <p:cNvSpPr/>
-          <p:nvPr/>
-        </p:nvSpPr>
-        <p:spPr>
-          <a:xfrm>
-            <a:off x="658368" y="3566160"/>
-            <a:ext cx="1554480" cy="365760"/>
-          </a:xfrm>
-          <a:prstGeom prst="rect">
-            <a:avLst/>
-          </a:prstGeom>
-          <a:noFill/>
-          <a:ln/>
-        </p:spPr>
-        <p:txBody>
-          <a:bodyPr wrap="square" lIns="0" tIns="0" rIns="0" bIns="0" rtlCol="0" anchor="ctr"/>
-          <a:lstStyle/>
-          <a:p>
-            <a:pPr indent="0" marL="0">
-              <a:buNone/>
-            </a:pPr>
-            <a:r>
-              <a:rPr lang="en-US" sz="1150" b="1" dirty="0">
-                <a:solidFill>
-                  <a:srgbClr val="272E52"/>
-                </a:solidFill>
-                <a:latin typeface="Arial" pitchFamily="34" charset="0"/>
-                <a:ea typeface="Arial" pitchFamily="34" charset="-122"/>
-                <a:cs typeface="Arial" pitchFamily="34" charset="-120"/>
-              </a:rPr>
-              <a:t>Reserve</a:t>
-            </a:r>
-            <a:endParaRPr lang="en-US" sz="1150" dirty="0"/>
-          </a:p>
-        </p:txBody>
-      </p:sp>
-      <p:sp>
-        <p:nvSpPr>
-          <p:cNvPr id="25" name="Text 23"/>
-          <p:cNvSpPr/>
-          <p:nvPr/>
-        </p:nvSpPr>
-        <p:spPr>
-          <a:xfrm>
-            <a:off x="2395728" y="3566160"/>
-            <a:ext cx="731520" cy="365760"/>
-          </a:xfrm>
-          <a:prstGeom prst="rect">
-            <a:avLst/>
-          </a:prstGeom>
-          <a:noFill/>
-          <a:ln/>
-        </p:spPr>
-        <p:txBody>
-          <a:bodyPr wrap="square" lIns="0" tIns="0" rIns="0" bIns="0" rtlCol="0" anchor="ctr"/>
-          <a:lstStyle/>
-          <a:p>
-            <a:pPr indent="0" marL="0">
-              <a:buNone/>
-            </a:pPr>
-            <a:r>
-              <a:rPr lang="en-US" sz="1150" dirty="0">
-                <a:solidFill>
-                  <a:srgbClr val="434A63"/>
-                </a:solidFill>
-                <a:latin typeface="Arial" pitchFamily="34" charset="0"/>
-                <a:ea typeface="Arial" pitchFamily="34" charset="-122"/>
-                <a:cs typeface="Arial" pitchFamily="34" charset="-120"/>
-              </a:rPr>
-              <a:t>–</a:t>
-            </a:r>
-            <a:endParaRPr lang="en-US" sz="1150" dirty="0"/>
-          </a:p>
-        </p:txBody>
-      </p:sp>
-      <p:sp>
-        <p:nvSpPr>
-          <p:cNvPr id="26" name="Text 24"/>
-          <p:cNvSpPr/>
-          <p:nvPr/>
-        </p:nvSpPr>
-        <p:spPr>
-          <a:xfrm>
-            <a:off x="3310128" y="3566160"/>
-            <a:ext cx="5175504" cy="365760"/>
-          </a:xfrm>
-          <a:prstGeom prst="rect">
-            <a:avLst/>
-          </a:prstGeom>
-          <a:noFill/>
-          <a:ln/>
-        </p:spPr>
-        <p:txBody>
-          <a:bodyPr wrap="square" lIns="0" tIns="0" rIns="0" bIns="0" rtlCol="0" anchor="ctr"/>
-          <a:lstStyle/>
-          <a:p>
-            <a:pPr indent="0" marL="0">
-              <a:buNone/>
-            </a:pPr>
-            <a:r>
-              <a:rPr lang="en-US" sz="1150" dirty="0">
-                <a:solidFill>
-                  <a:srgbClr val="434A63"/>
-                </a:solidFill>
-                <a:latin typeface="Arial" pitchFamily="34" charset="0"/>
-                <a:ea typeface="Arial" pitchFamily="34" charset="-122"/>
-                <a:cs typeface="Arial" pitchFamily="34" charset="-120"/>
-              </a:rPr>
-              <a:t>.240 bis .255 bleiben frei – Platz zum Wachsen</a:t>
-            </a:r>
-            <a:endParaRPr lang="en-US" sz="1150" dirty="0"/>
-          </a:p>
-        </p:txBody>
-      </p:sp>
-      <p:sp>
-        <p:nvSpPr>
-          <p:cNvPr id="27" name="Shape 25"/>
-          <p:cNvSpPr/>
-          <p:nvPr/>
-        </p:nvSpPr>
-        <p:spPr>
-          <a:xfrm>
-            <a:off x="566928" y="4160520"/>
+      <p:pic>
+        <p:nvPicPr>
+          <p:cNvPr id="23" name="Image 0" descr="/Users/jacobmenge/Desktop/kurs-26.2b-orga/folienwerkstatt/assets/diagramme/subnetz-plan.png">    </p:cNvPr>
+          <p:cNvPicPr>
+            <a:picLocks noChangeAspect="1"/>
+          </p:cNvPicPr>
+          <p:nvPr/>
+        </p:nvPicPr>
+        <p:blipFill>
+          <a:blip r:embed="rId1"/>
+          <a:stretch>
+            <a:fillRect/>
+          </a:stretch>
+        </p:blipFill>
+        <p:spPr>
+          <a:xfrm>
+            <a:off x="566928" y="3364992"/>
+            <a:ext cx="8010144" cy="777240"/>
+          </a:xfrm>
+          <a:prstGeom prst="rect">
+            <a:avLst/>
+          </a:prstGeom>
+        </p:spPr>
+      </p:pic>
+      <p:sp>
+        <p:nvSpPr>
+          <p:cNvPr id="24" name="Shape 21"/>
+          <p:cNvSpPr/>
+          <p:nvPr/>
+        </p:nvSpPr>
+        <p:spPr>
+          <a:xfrm>
+            <a:off x="566928" y="4288536"/>
             <a:ext cx="32004" cy="256032"/>
           </a:xfrm>
           <a:prstGeom prst="rect">
@@ -11989,13 +11876,13 @@
       </p:sp>
       <p:sp>
         <p:nvSpPr>
-          <p:cNvPr id="28" name="Text 26"/>
-          <p:cNvSpPr/>
-          <p:nvPr/>
-        </p:nvSpPr>
-        <p:spPr>
-          <a:xfrm>
-            <a:off x="749808" y="4114800"/>
+          <p:cNvPr id="25" name="Text 22"/>
+          <p:cNvSpPr/>
+          <p:nvPr/>
+        </p:nvSpPr>
+        <p:spPr>
+          <a:xfrm>
+            <a:off x="749808" y="4242816"/>
             <a:ext cx="7827264" cy="402336"/>
           </a:xfrm>
           <a:prstGeom prst="rect">
@@ -12020,7 +11907,7 @@
                 <a:ea typeface="Arial" pitchFamily="34" charset="-122"/>
                 <a:cs typeface="Arial" pitchFamily="34" charset="-120"/>
               </a:rPr>
-              <a:t>Größte zuerst vermeidet Lücken. Probe: 128 + 64 + 32 + 16 = 240 ≤ 256 – passt.</a:t>
+              <a:t>Größte zuerst vermeidet Lücken. Probe: 128 + 64 + 32 + 16 = 240 ≤ 256 – der Rest bleibt Reserve.</a:t>
             </a:r>
             <a:endParaRPr lang="en-US" sz="1200" dirty="0"/>
           </a:p>
@@ -12028,7 +11915,7 @@
       </p:sp>
       <p:sp>
         <p:nvSpPr>
-          <p:cNvPr id="29" name="Shape 27"/>
+          <p:cNvPr id="26" name="Shape 23"/>
           <p:cNvSpPr/>
           <p:nvPr/>
         </p:nvSpPr>
@@ -12051,7 +11938,7 @@
       </p:sp>
       <p:sp>
         <p:nvSpPr>
-          <p:cNvPr id="30" name="Text 28"/>
+          <p:cNvPr id="27" name="Text 24"/>
           <p:cNvSpPr/>
           <p:nvPr/>
         </p:nvSpPr>
@@ -12090,7 +11977,7 @@
       </p:sp>
       <p:sp>
         <p:nvSpPr>
-          <p:cNvPr id="31" name="Text 29"/>
+          <p:cNvPr id="28" name="Text 25"/>
           <p:cNvSpPr/>
           <p:nvPr/>
         </p:nvSpPr>

</xml_diff>